<commit_message>
docs: scrub display name from presentation decks
</commit_message>
<xml_diff>
--- a/deliverables/project-initiation/05-工业路由器装配MES-方案汇报-rehearsal.pptx
+++ b/deliverables/project-initiation/05-工业路由器装配MES-方案汇报-rehearsal.pptx
@@ -3189,7 +3189,7 @@
                 <a:ea typeface="Microsoft YaHei"/>
                 <a:cs typeface="Microsoft YaHei"/>
               </a:rPr>
-              <a:t>高级售前工程师  李文韬</a:t>
+              <a:t>高级售前工程师  李先生</a:t>
             </a:r>
           </a:p>
         </p:txBody>
@@ -19284,7 +19284,7 @@
                 <a:ea typeface="Microsoft YaHei"/>
                 <a:cs typeface="Microsoft YaHei"/>
               </a:rPr>
-              <a:t>高级售前工程师  李文韬</a:t>
+              <a:t>高级售前工程师  李先生</a:t>
             </a:r>
           </a:p>
         </p:txBody>

</xml_diff>